<commit_message>
feat(titration): show soll-werte in PP
</commit_message>
<xml_diff>
--- a/sem-3_titration/presentation/BCH3_WS2025_GlycinTitration_Results.pptx
+++ b/sem-3_titration/presentation/BCH3_WS2025_GlycinTitration_Results.pptx
@@ -40410,7 +40410,7 @@
         </p:nvSpPr>
         <p:spPr>
           <a:xfrm>
-            <a:off x="6010283" y="1434263"/>
+            <a:off x="6010283" y="1385276"/>
             <a:ext cx="2676525" cy="451035"/>
           </a:xfrm>
           <a:custGeom>
@@ -41157,7 +41157,7 @@
         </p:nvSpPr>
         <p:spPr>
           <a:xfrm rot="10800000">
-            <a:off x="6010281" y="2655150"/>
+            <a:off x="6010281" y="2638821"/>
             <a:ext cx="2676525" cy="451035"/>
           </a:xfrm>
           <a:custGeom>
@@ -47596,14 +47596,13 @@
         </p:nvPicPr>
         <p:blipFill>
           <a:blip r:embed="rId3"/>
-          <a:stretch>
-            <a:fillRect/>
-          </a:stretch>
+          <a:srcRect/>
+          <a:stretch/>
         </p:blipFill>
         <p:spPr>
           <a:xfrm>
-            <a:off x="558800" y="967540"/>
-            <a:ext cx="8229600" cy="4118810"/>
+            <a:off x="601001" y="967540"/>
+            <a:ext cx="8145197" cy="4118810"/>
           </a:xfrm>
           <a:prstGeom prst="rect">
             <a:avLst/>
@@ -49350,8 +49349,8 @@
         </p:blipFill>
         <p:spPr>
           <a:xfrm>
-            <a:off x="715211" y="967540"/>
-            <a:ext cx="7916777" cy="4118810"/>
+            <a:off x="727579" y="967540"/>
+            <a:ext cx="7892041" cy="4118810"/>
           </a:xfrm>
           <a:prstGeom prst="rect">
             <a:avLst/>
@@ -49486,8 +49485,8 @@
         </p:blipFill>
         <p:spPr>
           <a:xfrm>
-            <a:off x="715211" y="967540"/>
-            <a:ext cx="7916777" cy="4118809"/>
+            <a:off x="727579" y="967540"/>
+            <a:ext cx="7892041" cy="4118810"/>
           </a:xfrm>
           <a:prstGeom prst="rect">
             <a:avLst/>
@@ -49634,8 +49633,8 @@
         </p:blipFill>
         <p:spPr>
           <a:xfrm>
-            <a:off x="715211" y="967540"/>
-            <a:ext cx="7916776" cy="4118809"/>
+            <a:off x="727579" y="967540"/>
+            <a:ext cx="7892039" cy="4118809"/>
           </a:xfrm>
           <a:prstGeom prst="rect">
             <a:avLst/>

</xml_diff>

<commit_message>
fix(titration): lowlight the undone AA goals
</commit_message>
<xml_diff>
--- a/sem-3_titration/presentation/BCH3_WS2025_GlycinTitration_Results.pptx
+++ b/sem-3_titration/presentation/BCH3_WS2025_GlycinTitration_Results.pptx
@@ -43663,38 +43663,7 @@
             </a:bodyPr>
             <a:lstStyle/>
             <a:p>
-              <a:pPr marL="0" lvl="0" indent="0" algn="l" rtl="0">
-                <a:spcBef>
-                  <a:spcPts val="0"/>
-                </a:spcBef>
-                <a:spcAft>
-                  <a:spcPts val="0"/>
-                </a:spcAft>
-                <a:buNone/>
-              </a:pPr>
-              <a:r>
-                <a:rPr lang="en-US" dirty="0">
-                  <a:solidFill>
-                    <a:schemeClr val="dk2"/>
-                  </a:solidFill>
-                  <a:latin typeface="Catamaran"/>
-                  <a:ea typeface="Catamaran"/>
-                  <a:cs typeface="Catamaran"/>
-                  <a:sym typeface="Catamaran"/>
-                </a:rPr>
-                <a:t>Lysin</a:t>
-              </a:r>
-              <a:br>
-                <a:rPr lang="en-US" dirty="0">
-                  <a:solidFill>
-                    <a:schemeClr val="dk2"/>
-                  </a:solidFill>
-                  <a:latin typeface="Catamaran"/>
-                  <a:ea typeface="Catamaran"/>
-                  <a:cs typeface="Catamaran"/>
-                  <a:sym typeface="Catamaran"/>
-                </a:rPr>
-              </a:br>
+              <a:pPr lvl="0"/>
               <a:r>
                 <a:rPr lang="en-US" dirty="0" err="1">
                   <a:solidFill>
@@ -43705,7 +43674,7 @@
                   <a:cs typeface="Catamaran"/>
                   <a:sym typeface="Catamaran"/>
                 </a:rPr>
-                <a:t>Glutaminsäure</a:t>
+                <a:t>Histidin</a:t>
               </a:r>
               <a:endParaRPr lang="en-US" dirty="0">
                 <a:solidFill>
@@ -43728,6 +43697,41 @@
                 <a:buNone/>
               </a:pPr>
               <a:r>
+                <a:rPr lang="en-US" dirty="0">
+                  <a:solidFill>
+                    <a:schemeClr val="dk2"/>
+                  </a:solidFill>
+                  <a:latin typeface="Catamaran"/>
+                  <a:ea typeface="Catamaran"/>
+                  <a:cs typeface="Catamaran"/>
+                  <a:sym typeface="Catamaran"/>
+                </a:rPr>
+                <a:t>( Lysin</a:t>
+              </a:r>
+              <a:br>
+                <a:rPr lang="en-US" dirty="0">
+                  <a:solidFill>
+                    <a:schemeClr val="dk2"/>
+                  </a:solidFill>
+                  <a:latin typeface="Catamaran"/>
+                  <a:ea typeface="Catamaran"/>
+                  <a:cs typeface="Catamaran"/>
+                  <a:sym typeface="Catamaran"/>
+                </a:rPr>
+              </a:br>
+              <a:r>
+                <a:rPr lang="en-US" dirty="0">
+                  <a:solidFill>
+                    <a:schemeClr val="dk2"/>
+                  </a:solidFill>
+                  <a:latin typeface="Catamaran"/>
+                  <a:ea typeface="Catamaran"/>
+                  <a:cs typeface="Catamaran"/>
+                  <a:sym typeface="Catamaran"/>
+                </a:rPr>
+                <a:t>  </a:t>
+              </a:r>
+              <a:r>
                 <a:rPr lang="en-US" dirty="0" err="1">
                   <a:solidFill>
                     <a:schemeClr val="dk2"/>
@@ -43737,8 +43741,31 @@
                   <a:cs typeface="Catamaran"/>
                   <a:sym typeface="Catamaran"/>
                 </a:rPr>
-                <a:t>Histidin</a:t>
+                <a:t>Glutaminsäure</a:t>
               </a:r>
+              <a:r>
+                <a:rPr lang="en-US" dirty="0">
+                  <a:solidFill>
+                    <a:schemeClr val="dk2"/>
+                  </a:solidFill>
+                  <a:latin typeface="Catamaran"/>
+                  <a:ea typeface="Catamaran"/>
+                  <a:cs typeface="Catamaran"/>
+                  <a:sym typeface="Catamaran"/>
+                </a:rPr>
+                <a:t> )</a:t>
+              </a:r>
+            </a:p>
+            <a:p>
+              <a:pPr marL="0" lvl="0" indent="0" algn="l" rtl="0">
+                <a:spcBef>
+                  <a:spcPts val="0"/>
+                </a:spcBef>
+                <a:spcAft>
+                  <a:spcPts val="0"/>
+                </a:spcAft>
+                <a:buNone/>
+              </a:pPr>
               <a:endParaRPr dirty="0">
                 <a:solidFill>
                   <a:schemeClr val="dk2"/>
@@ -46660,8 +46687,8 @@
             <a:chExt cx="2469463" cy="1428598"/>
           </a:xfrm>
         </p:grpSpPr>
-        <mc:AlternateContent xmlns:mc="http://schemas.openxmlformats.org/markup-compatibility/2006">
-          <mc:Choice xmlns:a14="http://schemas.microsoft.com/office/drawing/2010/main" Requires="a14">
+        <mc:AlternateContent xmlns:mc="http://schemas.openxmlformats.org/markup-compatibility/2006" xmlns:a14="http://schemas.microsoft.com/office/drawing/2010/main">
+          <mc:Choice Requires="a14">
             <p:sp>
               <p:nvSpPr>
                 <p:cNvPr id="1593" name="Google Shape;1593;p35">
@@ -46861,7 +46888,7 @@
               </p:txBody>
             </p:sp>
           </mc:Choice>
-          <mc:Fallback>
+          <mc:Fallback xmlns="">
             <p:sp>
               <p:nvSpPr>
                 <p:cNvPr id="1593" name="Google Shape;1593;p35">
@@ -49503,13 +49530,13 @@
   <p:clrMapOvr>
     <a:masterClrMapping/>
   </p:clrMapOvr>
-  <mc:AlternateContent xmlns:mc="http://schemas.openxmlformats.org/markup-compatibility/2006">
-    <mc:Choice xmlns:p14="http://schemas.microsoft.com/office/powerpoint/2010/main" Requires="p14">
+  <mc:AlternateContent xmlns:mc="http://schemas.openxmlformats.org/markup-compatibility/2006" xmlns:p14="http://schemas.microsoft.com/office/powerpoint/2010/main">
+    <mc:Choice Requires="p14">
       <p:transition spd="med" p14:dur="700">
         <p:fade/>
       </p:transition>
     </mc:Choice>
-    <mc:Fallback>
+    <mc:Fallback xmlns="">
       <p:transition spd="med">
         <p:fade/>
       </p:transition>
@@ -49651,13 +49678,13 @@
   <p:clrMapOvr>
     <a:masterClrMapping/>
   </p:clrMapOvr>
-  <mc:AlternateContent xmlns:mc="http://schemas.openxmlformats.org/markup-compatibility/2006">
-    <mc:Choice xmlns:p14="http://schemas.microsoft.com/office/powerpoint/2010/main" Requires="p14">
+  <mc:AlternateContent xmlns:mc="http://schemas.openxmlformats.org/markup-compatibility/2006" xmlns:p14="http://schemas.microsoft.com/office/powerpoint/2010/main">
+    <mc:Choice Requires="p14">
       <p:transition spd="med" p14:dur="700">
         <p:fade/>
       </p:transition>
     </mc:Choice>
-    <mc:Fallback>
+    <mc:Fallback xmlns="">
       <p:transition spd="med">
         <p:fade/>
       </p:transition>

</xml_diff>

<commit_message>
feat(titration): add slide numbers
</commit_message>
<xml_diff>
--- a/sem-3_titration/presentation/BCH3_WS2025_GlycinTitration_Results.pptx
+++ b/sem-3_titration/presentation/BCH3_WS2025_GlycinTitration_Results.pptx
@@ -38565,6 +38565,58 @@
           </a:p>
         </p:txBody>
       </p:sp>
+      <p:sp>
+        <p:nvSpPr>
+          <p:cNvPr id="2" name="TextBox 1">
+            <a:extLst>
+              <a:ext uri="{FF2B5EF4-FFF2-40B4-BE49-F238E27FC236}">
+                <a16:creationId xmlns:a16="http://schemas.microsoft.com/office/drawing/2014/main" id="{6A47FCFE-3082-C6E3-A7EB-0673742C3172}"/>
+              </a:ext>
+            </a:extLst>
+          </p:cNvPr>
+          <p:cNvSpPr txBox="1"/>
+          <p:nvPr userDrawn="1"/>
+        </p:nvSpPr>
+        <p:spPr>
+          <a:xfrm>
+            <a:off x="8015786" y="4817527"/>
+            <a:ext cx="1110018" cy="307777"/>
+          </a:xfrm>
+          <a:prstGeom prst="rect">
+            <a:avLst/>
+          </a:prstGeom>
+          <a:noFill/>
+        </p:spPr>
+        <p:txBody>
+          <a:bodyPr wrap="square" rtlCol="0">
+            <a:spAutoFit/>
+          </a:bodyPr>
+          <a:lstStyle/>
+          <a:p>
+            <a:pPr algn="r"/>
+            <a:fld id="{E8CCEAD0-4149-4ACD-A3AA-20A6475603D4}" type="slidenum">
+              <a:rPr lang="de-AT" smtClean="0">
+                <a:solidFill>
+                  <a:schemeClr val="bg1">
+                    <a:lumMod val="95000"/>
+                  </a:schemeClr>
+                </a:solidFill>
+                <a:latin typeface="Love Ya Like A Sister" panose="02000000000000000000" pitchFamily="2" charset="0"/>
+              </a:rPr>
+              <a:pPr algn="r"/>
+              <a:t>‹#›</a:t>
+            </a:fld>
+            <a:endParaRPr lang="de-AT" dirty="0">
+              <a:solidFill>
+                <a:schemeClr val="bg1">
+                  <a:lumMod val="95000"/>
+                </a:schemeClr>
+              </a:solidFill>
+              <a:latin typeface="Love Ya Like A Sister" panose="02000000000000000000" pitchFamily="2" charset="0"/>
+            </a:endParaRPr>
+          </a:p>
+        </p:txBody>
+      </p:sp>
     </p:spTree>
   </p:cSld>
   <p:clrMap bg1="lt1" tx1="dk1" bg2="dk2" tx2="lt2" accent1="accent1" accent2="accent2" accent3="accent3" accent4="accent4" accent5="accent5" accent6="accent6" hlink="hlink" folHlink="folHlink"/>
@@ -38580,7 +38632,7 @@
     <p:sldLayoutId id="2147483657" r:id="rId9"/>
     <p:sldLayoutId id="2147483658" r:id="rId10"/>
   </p:sldLayoutIdLst>
-  <p:hf sldNum="0" hdr="0" ftr="0" dt="0"/>
+  <p:hf hdr="0" ftr="0" dt="0"/>
   <p:txStyles>
     <p:titleStyle>
       <a:defPPr marR="0" lvl="0" algn="l" rtl="0">

</xml_diff>

<commit_message>
feat(titration): add date for title
</commit_message>
<xml_diff>
--- a/sem-3_titration/presentation/BCH3_WS2025_GlycinTitration_Results.pptx
+++ b/sem-3_titration/presentation/BCH3_WS2025_GlycinTitration_Results.pptx
@@ -39453,7 +39453,14 @@
               <a:rPr lang="en" dirty="0"/>
               <a:t>Nathalie Sonnleitner, Tim Peko</a:t>
             </a:r>
-            <a:endParaRPr dirty="0"/>
+            <a:br>
+              <a:rPr lang="en" sz="1200" dirty="0"/>
+            </a:br>
+            <a:r>
+              <a:rPr lang="en" sz="1200" dirty="0"/>
+              <a:t>19.01.2026</a:t>
+            </a:r>
+            <a:endParaRPr sz="1200" dirty="0"/>
           </a:p>
         </p:txBody>
       </p:sp>

</xml_diff>